<commit_message>
Stop the deck overclaiming, and remove documents with stale results
The motivation slide said the LLM "states the reason for every order". It
does not, by design: it restates computed facts and is never asked why.
It also stated as fact that RL adapts where a formula cannot, which the
results did not bear out; it is now worded as the hypothesis tested.

Removed the August deck and dossier (pounds, pre-tuning numbers, Phase 9
described as future work) and NEXT_SESSION.md (says Phase 9 is paused).
All three are in git history if ever needed.
</commit_message>
<xml_diff>
--- a/reports/SupplyAI-RL_Mid_Project_Review.pptx
+++ b/reports/SupplyAI-RL_Mid_Project_Review.pptx
@@ -9011,7 +9011,7 @@
                             <a:srgbClr val="202020"/>
                           </a:solidFill>
                         </a:rPr>
-                        <a:t>Plain-English reason for every order decision</a:t>
+                        <a:t>Plain-English explanation of every order decision</a:t>
                       </a:r>
                     </a:p>
                   </a:txBody>
@@ -13614,7 +13614,7 @@
             </a:pPr>
             <a:r>
               <a:rPr lang="en-IN" sz="1800" b="1" dirty="0"/>
-              <a:t>Reinforcement learning can express what a formula cannot: a joint ordering and sourcing policy that adapts to season, volatility and supplier state.</a:t>
+              <a:t>Our hypothesis: RL can learn a joint ordering and sourcing policy that adapts to season, volatility and supplier state, which a formula cannot.</a:t>
             </a:r>
           </a:p>
           <a:p>
@@ -13642,7 +13642,7 @@
             </a:pPr>
             <a:r>
               <a:rPr lang="en-IN" sz="1500" b="0" dirty="0"/>
-              <a:t>Hence the motivation: pair an RL decision-maker with an LLM that states the reason for every order in business language.</a:t>
+              <a:t>Hence the motivation: pair an RL decision-maker with an LLM that explains the situation behind every order in business language, every number checked.</a:t>
             </a:r>
           </a:p>
         </p:txBody>

</xml_diff>